<commit_message>
alright folks, it's showtime
</commit_message>
<xml_diff>
--- a/assets/CCR_A TODA MARCHA.pptx
+++ b/assets/CCR_A TODA MARCHA.pptx
@@ -280,19 +280,19 @@
 <pc:chgInfo xmlns:a="http://schemas.openxmlformats.org/drawingml/2006/main" xmlns:r="http://schemas.openxmlformats.org/officeDocument/2006/relationships" xmlns:ac="http://schemas.microsoft.com/office/drawing/2013/main/command" xmlns:pc="http://schemas.microsoft.com/office/powerpoint/2013/main/command">
   <pc:docChgLst>
     <pc:chgData name="juani vila bach" userId="140d79d91c36b714" providerId="LiveId" clId="{681BBBA0-CB6B-4408-8383-25A2ECA50787}"/>
-    <pc:docChg chg="modSld">
-      <pc:chgData name="juani vila bach" userId="140d79d91c36b714" providerId="LiveId" clId="{681BBBA0-CB6B-4408-8383-25A2ECA50787}" dt="2025-12-09T20:04:18.368" v="13" actId="14100"/>
+    <pc:docChg chg="custSel modSld">
+      <pc:chgData name="juani vila bach" userId="140d79d91c36b714" providerId="LiveId" clId="{681BBBA0-CB6B-4408-8383-25A2ECA50787}" dt="2026-03-26T20:50:26.623" v="15" actId="478"/>
       <pc:docMkLst>
         <pc:docMk/>
       </pc:docMkLst>
-      <pc:sldChg chg="addSp modSp mod modNotes">
-        <pc:chgData name="juani vila bach" userId="140d79d91c36b714" providerId="LiveId" clId="{681BBBA0-CB6B-4408-8383-25A2ECA50787}" dt="2025-12-09T20:04:18.368" v="13" actId="14100"/>
+      <pc:sldChg chg="addSp delSp modSp mod modNotes">
+        <pc:chgData name="juani vila bach" userId="140d79d91c36b714" providerId="LiveId" clId="{681BBBA0-CB6B-4408-8383-25A2ECA50787}" dt="2026-03-26T20:50:26.623" v="15" actId="478"/>
         <pc:sldMkLst>
           <pc:docMk/>
           <pc:sldMk cId="0" sldId="256"/>
         </pc:sldMkLst>
-        <pc:spChg chg="add mod">
-          <ac:chgData name="juani vila bach" userId="140d79d91c36b714" providerId="LiveId" clId="{681BBBA0-CB6B-4408-8383-25A2ECA50787}" dt="2025-12-09T20:04:18.368" v="13" actId="14100"/>
+        <pc:spChg chg="add del mod">
+          <ac:chgData name="juani vila bach" userId="140d79d91c36b714" providerId="LiveId" clId="{681BBBA0-CB6B-4408-8383-25A2ECA50787}" dt="2026-03-26T20:50:26.623" v="15" actId="478"/>
           <ac:spMkLst>
             <pc:docMk/>
             <pc:sldMk cId="0" sldId="256"/>
@@ -6402,70 +6402,6 @@
                 <a:sym typeface="Public Sans"/>
               </a:rPr>
               <a:t>&lt;&lt;Nombre y Apellido&gt;&gt;</a:t>
-            </a:r>
-            <a:endParaRPr sz="3483" b="1" dirty="0">
-              <a:solidFill>
-                <a:schemeClr val="dk1"/>
-              </a:solidFill>
-              <a:latin typeface="Public Sans"/>
-              <a:ea typeface="Public Sans"/>
-              <a:cs typeface="Public Sans"/>
-              <a:sym typeface="Public Sans"/>
-            </a:endParaRPr>
-          </a:p>
-        </p:txBody>
-      </p:sp>
-      <p:sp>
-        <p:nvSpPr>
-          <p:cNvPr id="2" name="Google Shape;54;p13">
-            <a:extLst>
-              <a:ext uri="{FF2B5EF4-FFF2-40B4-BE49-F238E27FC236}">
-                <a16:creationId xmlns:a16="http://schemas.microsoft.com/office/drawing/2014/main" id="{8BB0DF57-51F2-21C6-1091-000AECBEF497}"/>
-              </a:ext>
-            </a:extLst>
-          </p:cNvPr>
-          <p:cNvSpPr txBox="1"/>
-          <p:nvPr/>
-        </p:nvSpPr>
-        <p:spPr>
-          <a:xfrm>
-            <a:off x="2119744" y="5989585"/>
-            <a:ext cx="5985165" cy="5077000"/>
-          </a:xfrm>
-          <a:prstGeom prst="rect">
-            <a:avLst/>
-          </a:prstGeom>
-          <a:noFill/>
-          <a:ln>
-            <a:noFill/>
-          </a:ln>
-        </p:spPr>
-        <p:txBody>
-          <a:bodyPr spcFirstLastPara="1" wrap="square" lIns="91425" tIns="91425" rIns="91425" bIns="91425" anchor="ctr" anchorCtr="0">
-            <a:noAutofit/>
-          </a:bodyPr>
-          <a:lstStyle/>
-          <a:p>
-            <a:pPr marL="0" lvl="0" indent="0" algn="ctr" rtl="0">
-              <a:spcBef>
-                <a:spcPts val="0"/>
-              </a:spcBef>
-              <a:spcAft>
-                <a:spcPts val="0"/>
-              </a:spcAft>
-              <a:buNone/>
-            </a:pPr>
-            <a:r>
-              <a:rPr lang="en" sz="3483" b="1" dirty="0">
-                <a:solidFill>
-                  <a:schemeClr val="dk1"/>
-                </a:solidFill>
-                <a:latin typeface="Public Sans"/>
-                <a:ea typeface="Public Sans"/>
-                <a:cs typeface="Public Sans"/>
-                <a:sym typeface="Public Sans"/>
-              </a:rPr>
-              <a:t>&lt;&lt;img&gt;&gt;</a:t>
             </a:r>
             <a:endParaRPr sz="3483" b="1" dirty="0">
               <a:solidFill>

</xml_diff>